<commit_message>
Fix side-by-side ZMQ diagram: consistent colors and inline bullets
Changes to slide 2 (side-by-side diagram):
- Bullet points now inside respective boxes (not below)
- Each box uses separate text box for consistent coloring:
  * Main Process: all ACCENT (blue)
  * Gaussian: all GREEN
  * Helper: all ORANGE
- Fixes issue where helper box borders were mixed orange/white
- Cleaner visual separation between components
- Flow description remains at bottom
</commit_message>
<xml_diff>
--- a/presentation/test_zmq_diagrams.pptx
+++ b/presentation/test_zmq_diagrams.pptx
@@ -3684,8 +3684,8 @@
         </p:nvSpPr>
         <p:spPr>
           <a:xfrm>
-            <a:off x="457200" y="1188720"/>
-            <a:ext cx="8229600" cy="5029200"/>
+            <a:off x="731520" y="1097280"/>
+            <a:ext cx="2926080" cy="1828800"/>
           </a:xfrm>
           <a:prstGeom prst="rect">
             <a:avLst/>
@@ -3699,8 +3699,11 @@
           <a:lstStyle/>
           <a:p>
             <a:pPr>
-              <a:spcAft>
-                <a:spcPts val="200"/>
+              <a:lnSpc>
+                <a:spcPct val="100000"/>
+              </a:lnSpc>
+              <a:spcAft>
+                <a:spcPts val="100"/>
               </a:spcAft>
               <a:defRPr sz="1100">
                 <a:solidFill>
@@ -3710,13 +3713,16 @@
               </a:defRPr>
             </a:pPr>
             <a:r>
-              <a:t>┌─────────────────────┐        ┌─────────────────────┐</a:t>
-            </a:r>
-          </a:p>
-          <a:p>
-            <a:pPr>
-              <a:spcAft>
-                <a:spcPts val="200"/>
+              <a:t>┌─────────────────────┐</a:t>
+            </a:r>
+          </a:p>
+          <a:p>
+            <a:pPr>
+              <a:lnSpc>
+                <a:spcPct val="100000"/>
+              </a:lnSpc>
+              <a:spcAft>
+                <a:spcPts val="100"/>
               </a:spcAft>
               <a:defRPr sz="1100">
                 <a:solidFill>
@@ -3726,13 +3732,16 @@
               </a:defRPr>
             </a:pPr>
             <a:r>
-              <a:t>│  Main Process       │◀──────▶│  Gaussian 16        │</a:t>
-            </a:r>
-          </a:p>
-          <a:p>
-            <a:pPr>
-              <a:spcAft>
-                <a:spcPts val="200"/>
+              <a:t>│  Main Process       │</a:t>
+            </a:r>
+          </a:p>
+          <a:p>
+            <a:pPr>
+              <a:lnSpc>
+                <a:spcPct val="100000"/>
+              </a:lnSpc>
+              <a:spcAft>
+                <a:spcPts val="100"/>
               </a:spcAft>
               <a:defRPr sz="1100">
                 <a:solidFill>
@@ -3742,13 +3751,16 @@
               </a:defRPr>
             </a:pPr>
             <a:r>
-              <a:t>│  (Python)           │  ZMQ   │  (Fortran)          │</a:t>
-            </a:r>
-          </a:p>
-          <a:p>
-            <a:pPr>
-              <a:spcAft>
-                <a:spcPts val="200"/>
+              <a:t>│  (Python)           │</a:t>
+            </a:r>
+          </a:p>
+          <a:p>
+            <a:pPr>
+              <a:lnSpc>
+                <a:spcPct val="100000"/>
+              </a:lnSpc>
+              <a:spcAft>
+                <a:spcPts val="100"/>
               </a:spcAft>
               <a:defRPr sz="1100">
                 <a:solidFill>
@@ -3758,77 +3770,444 @@
               </a:defRPr>
             </a:pPr>
             <a:r>
-              <a:t>└─────────────────────┘        └─────────────────────┘</a:t>
-            </a:r>
-          </a:p>
-          <a:p>
-            <a:pPr>
-              <a:spcAft>
-                <a:spcPts val="200"/>
+              <a:t>│                     │</a:t>
+            </a:r>
+          </a:p>
+          <a:p>
+            <a:pPr>
+              <a:lnSpc>
+                <a:spcPct val="100000"/>
+              </a:lnSpc>
+              <a:spcAft>
+                <a:spcPts val="100"/>
               </a:spcAft>
               <a:defRPr sz="1100">
                 <a:solidFill>
-                  <a:srgbClr val="C9D1D9"/>
-                </a:solidFill>
-                <a:latin typeface="Consolas"/>
-              </a:defRPr>
-            </a:pPr>
-            <a:r>
-              <a:t>  • ZMQ server                    • Freq calculation</a:t>
-            </a:r>
-          </a:p>
-          <a:p>
-            <a:pPr>
-              <a:spcAft>
-                <a:spcPts val="200"/>
+                  <a:srgbClr val="58A6FF"/>
+                </a:solidFill>
+                <a:latin typeface="Consolas"/>
+              </a:defRPr>
+            </a:pPr>
+            <a:r>
+              <a:t>│  • ZMQ server       │</a:t>
+            </a:r>
+          </a:p>
+          <a:p>
+            <a:pPr>
+              <a:lnSpc>
+                <a:spcPct val="100000"/>
+              </a:lnSpc>
+              <a:spcAft>
+                <a:spcPts val="100"/>
               </a:spcAft>
               <a:defRPr sz="1100">
                 <a:solidFill>
-                  <a:srgbClr val="C9D1D9"/>
-                </a:solidFill>
-                <a:latin typeface="Consolas"/>
-              </a:defRPr>
-            </a:pPr>
-            <a:r>
-              <a:t>  • ML dipole calc                • Calls external</a:t>
-            </a:r>
-          </a:p>
-          <a:p>
-            <a:pPr>
-              <a:spcAft>
-                <a:spcPts val="200"/>
+                  <a:srgbClr val="58A6FF"/>
+                </a:solidFill>
+                <a:latin typeface="Consolas"/>
+              </a:defRPr>
+            </a:pPr>
+            <a:r>
+              <a:t>│  • ML dipole calc   │</a:t>
+            </a:r>
+          </a:p>
+          <a:p>
+            <a:pPr>
+              <a:lnSpc>
+                <a:spcPct val="100000"/>
+              </a:lnSpc>
+              <a:spcAft>
+                <a:spcPts val="100"/>
               </a:spcAft>
               <a:defRPr sz="1100">
                 <a:solidFill>
+                  <a:srgbClr val="58A6FF"/>
+                </a:solidFill>
+                <a:latin typeface="Consolas"/>
+              </a:defRPr>
+            </a:pPr>
+            <a:r>
+              <a:t>└─────────────────────┘</a:t>
+            </a:r>
+          </a:p>
+        </p:txBody>
+      </p:sp>
+      <p:sp>
+        <p:nvSpPr>
+          <p:cNvPr id="4" name="TextBox 3"/>
+          <p:cNvSpPr txBox="1"/>
+          <p:nvPr/>
+        </p:nvSpPr>
+        <p:spPr>
+          <a:xfrm>
+            <a:off x="5303520" y="1097280"/>
+            <a:ext cx="2926080" cy="1828800"/>
+          </a:xfrm>
+          <a:prstGeom prst="rect">
+            <a:avLst/>
+          </a:prstGeom>
+          <a:noFill/>
+        </p:spPr>
+        <p:txBody>
+          <a:bodyPr wrap="none">
+            <a:spAutoFit/>
+          </a:bodyPr>
+          <a:lstStyle/>
+          <a:p>
+            <a:pPr>
+              <a:lnSpc>
+                <a:spcPct val="100000"/>
+              </a:lnSpc>
+              <a:spcAft>
+                <a:spcPts val="100"/>
+              </a:spcAft>
+              <a:defRPr sz="1100">
+                <a:solidFill>
+                  <a:srgbClr val="57AB5A"/>
+                </a:solidFill>
+                <a:latin typeface="Consolas"/>
+              </a:defRPr>
+            </a:pPr>
+            <a:r>
+              <a:t>┌─────────────────────┐</a:t>
+            </a:r>
+          </a:p>
+          <a:p>
+            <a:pPr>
+              <a:lnSpc>
+                <a:spcPct val="100000"/>
+              </a:lnSpc>
+              <a:spcAft>
+                <a:spcPts val="100"/>
+              </a:spcAft>
+              <a:defRPr sz="1100">
+                <a:solidFill>
+                  <a:srgbClr val="57AB5A"/>
+                </a:solidFill>
+                <a:latin typeface="Consolas"/>
+              </a:defRPr>
+            </a:pPr>
+            <a:r>
+              <a:t>│  Gaussian 16        │</a:t>
+            </a:r>
+          </a:p>
+          <a:p>
+            <a:pPr>
+              <a:lnSpc>
+                <a:spcPct val="100000"/>
+              </a:lnSpc>
+              <a:spcAft>
+                <a:spcPts val="100"/>
+              </a:spcAft>
+              <a:defRPr sz="1100">
+                <a:solidFill>
+                  <a:srgbClr val="57AB5A"/>
+                </a:solidFill>
+                <a:latin typeface="Consolas"/>
+              </a:defRPr>
+            </a:pPr>
+            <a:r>
+              <a:t>│  (Fortran)          │</a:t>
+            </a:r>
+          </a:p>
+          <a:p>
+            <a:pPr>
+              <a:lnSpc>
+                <a:spcPct val="100000"/>
+              </a:lnSpc>
+              <a:spcAft>
+                <a:spcPts val="100"/>
+              </a:spcAft>
+              <a:defRPr sz="1100">
+                <a:solidFill>
+                  <a:srgbClr val="57AB5A"/>
+                </a:solidFill>
+                <a:latin typeface="Consolas"/>
+              </a:defRPr>
+            </a:pPr>
+            <a:r>
+              <a:t>│                     │</a:t>
+            </a:r>
+          </a:p>
+          <a:p>
+            <a:pPr>
+              <a:lnSpc>
+                <a:spcPct val="100000"/>
+              </a:lnSpc>
+              <a:spcAft>
+                <a:spcPts val="100"/>
+              </a:spcAft>
+              <a:defRPr sz="1100">
+                <a:solidFill>
+                  <a:srgbClr val="57AB5A"/>
+                </a:solidFill>
+                <a:latin typeface="Consolas"/>
+              </a:defRPr>
+            </a:pPr>
+            <a:r>
+              <a:t>│  • Freq calculation │</a:t>
+            </a:r>
+          </a:p>
+          <a:p>
+            <a:pPr>
+              <a:lnSpc>
+                <a:spcPct val="100000"/>
+              </a:lnSpc>
+              <a:spcAft>
+                <a:spcPts val="100"/>
+              </a:spcAft>
+              <a:defRPr sz="1100">
+                <a:solidFill>
+                  <a:srgbClr val="57AB5A"/>
+                </a:solidFill>
+                <a:latin typeface="Consolas"/>
+              </a:defRPr>
+            </a:pPr>
+            <a:r>
+              <a:t>│  • Calls external   │</a:t>
+            </a:r>
+          </a:p>
+          <a:p>
+            <a:pPr>
+              <a:lnSpc>
+                <a:spcPct val="100000"/>
+              </a:lnSpc>
+              <a:spcAft>
+                <a:spcPts val="100"/>
+              </a:spcAft>
+              <a:defRPr sz="1100">
+                <a:solidFill>
+                  <a:srgbClr val="57AB5A"/>
+                </a:solidFill>
+                <a:latin typeface="Consolas"/>
+              </a:defRPr>
+            </a:pPr>
+            <a:r>
+              <a:t>└─────────────────────┘</a:t>
+            </a:r>
+          </a:p>
+        </p:txBody>
+      </p:sp>
+      <p:sp>
+        <p:nvSpPr>
+          <p:cNvPr id="5" name="TextBox 4"/>
+          <p:cNvSpPr txBox="1"/>
+          <p:nvPr/>
+        </p:nvSpPr>
+        <p:spPr>
+          <a:xfrm>
+            <a:off x="3657600" y="1828800"/>
+            <a:ext cx="1645920" cy="365760"/>
+          </a:xfrm>
+          <a:prstGeom prst="rect">
+            <a:avLst/>
+          </a:prstGeom>
+          <a:noFill/>
+        </p:spPr>
+        <p:txBody>
+          <a:bodyPr wrap="none">
+            <a:spAutoFit/>
+          </a:bodyPr>
+          <a:lstStyle/>
+          <a:p>
+            <a:pPr algn="ctr">
+              <a:defRPr sz="1100">
+                <a:solidFill>
                   <a:srgbClr val="8B949E"/>
                 </a:solidFill>
                 <a:latin typeface="Consolas"/>
               </a:defRPr>
             </a:pPr>
             <a:r>
-              <a:t>         ▲                                 │</a:t>
-            </a:r>
-          </a:p>
-          <a:p>
-            <a:pPr>
-              <a:spcAft>
-                <a:spcPts val="200"/>
+              <a:t>◀──ZMQ──▶</a:t>
+            </a:r>
+          </a:p>
+        </p:txBody>
+      </p:sp>
+      <p:sp>
+        <p:nvSpPr>
+          <p:cNvPr id="6" name="TextBox 5"/>
+          <p:cNvSpPr txBox="1"/>
+          <p:nvPr/>
+        </p:nvSpPr>
+        <p:spPr>
+          <a:xfrm>
+            <a:off x="2743200" y="3474720"/>
+            <a:ext cx="3840480" cy="1463040"/>
+          </a:xfrm>
+          <a:prstGeom prst="rect">
+            <a:avLst/>
+          </a:prstGeom>
+          <a:noFill/>
+        </p:spPr>
+        <p:txBody>
+          <a:bodyPr wrap="none">
+            <a:spAutoFit/>
+          </a:bodyPr>
+          <a:lstStyle/>
+          <a:p>
+            <a:pPr>
+              <a:lnSpc>
+                <a:spcPct val="100000"/>
+              </a:lnSpc>
+              <a:spcAft>
+                <a:spcPts val="100"/>
               </a:spcAft>
               <a:defRPr sz="1100">
                 <a:solidFill>
+                  <a:srgbClr val="DB6D28"/>
+                </a:solidFill>
+                <a:latin typeface="Consolas"/>
+              </a:defRPr>
+            </a:pPr>
+            <a:r>
+              <a:t>┌─────────────────────────────┐</a:t>
+            </a:r>
+          </a:p>
+          <a:p>
+            <a:pPr>
+              <a:lnSpc>
+                <a:spcPct val="100000"/>
+              </a:lnSpc>
+              <a:spcAft>
+                <a:spcPts val="100"/>
+              </a:spcAft>
+              <a:defRPr sz="1100">
+                <a:solidFill>
+                  <a:srgbClr val="DB6D28"/>
+                </a:solidFill>
+                <a:latin typeface="Consolas"/>
+              </a:defRPr>
+            </a:pPr>
+            <a:r>
+              <a:t>│  Helper (gm_helper.py)      │</a:t>
+            </a:r>
+          </a:p>
+          <a:p>
+            <a:pPr>
+              <a:lnSpc>
+                <a:spcPct val="100000"/>
+              </a:lnSpc>
+              <a:spcAft>
+                <a:spcPts val="100"/>
+              </a:spcAft>
+              <a:defRPr sz="1100">
+                <a:solidFill>
+                  <a:srgbClr val="DB6D28"/>
+                </a:solidFill>
+                <a:latin typeface="Consolas"/>
+              </a:defRPr>
+            </a:pPr>
+            <a:r>
+              <a:t>│  • Bridge between processes │</a:t>
+            </a:r>
+          </a:p>
+          <a:p>
+            <a:pPr>
+              <a:lnSpc>
+                <a:spcPct val="100000"/>
+              </a:lnSpc>
+              <a:spcAft>
+                <a:spcPts val="100"/>
+              </a:spcAft>
+              <a:defRPr sz="1100">
+                <a:solidFill>
+                  <a:srgbClr val="DB6D28"/>
+                </a:solidFill>
+                <a:latin typeface="Consolas"/>
+              </a:defRPr>
+            </a:pPr>
+            <a:r>
+              <a:t>│  • Sends file paths         │</a:t>
+            </a:r>
+          </a:p>
+          <a:p>
+            <a:pPr>
+              <a:lnSpc>
+                <a:spcPct val="100000"/>
+              </a:lnSpc>
+              <a:spcAft>
+                <a:spcPts val="100"/>
+              </a:spcAft>
+              <a:defRPr sz="1100">
+                <a:solidFill>
+                  <a:srgbClr val="DB6D28"/>
+                </a:solidFill>
+                <a:latin typeface="Consolas"/>
+              </a:defRPr>
+            </a:pPr>
+            <a:r>
+              <a:t>│  • Waits for completion     │</a:t>
+            </a:r>
+          </a:p>
+          <a:p>
+            <a:pPr>
+              <a:lnSpc>
+                <a:spcPct val="100000"/>
+              </a:lnSpc>
+              <a:spcAft>
+                <a:spcPts val="100"/>
+              </a:spcAft>
+              <a:defRPr sz="1100">
+                <a:solidFill>
+                  <a:srgbClr val="DB6D28"/>
+                </a:solidFill>
+                <a:latin typeface="Consolas"/>
+              </a:defRPr>
+            </a:pPr>
+            <a:r>
+              <a:t>└─────────────────────────────┘</a:t>
+            </a:r>
+          </a:p>
+        </p:txBody>
+      </p:sp>
+      <p:sp>
+        <p:nvSpPr>
+          <p:cNvPr id="7" name="TextBox 6"/>
+          <p:cNvSpPr txBox="1"/>
+          <p:nvPr/>
+        </p:nvSpPr>
+        <p:spPr>
+          <a:xfrm>
+            <a:off x="1371600" y="3017520"/>
+            <a:ext cx="5943600" cy="548640"/>
+          </a:xfrm>
+          <a:prstGeom prst="rect">
+            <a:avLst/>
+          </a:prstGeom>
+          <a:noFill/>
+        </p:spPr>
+        <p:txBody>
+          <a:bodyPr wrap="none">
+            <a:spAutoFit/>
+          </a:bodyPr>
+          <a:lstStyle/>
+          <a:p>
+            <a:pPr>
+              <a:lnSpc>
+                <a:spcPct val="100000"/>
+              </a:lnSpc>
+              <a:spcAft>
+                <a:spcPts val="100"/>
+              </a:spcAft>
+              <a:defRPr sz="1100">
+                <a:solidFill>
                   <a:srgbClr val="8B949E"/>
                 </a:solidFill>
                 <a:latin typeface="Consolas"/>
               </a:defRPr>
             </a:pPr>
             <a:r>
-              <a:t>         │                                 │</a:t>
-            </a:r>
-          </a:p>
-          <a:p>
-            <a:pPr>
-              <a:spcAft>
-                <a:spcPts val="200"/>
+              <a:t>    ▲                       │</a:t>
+            </a:r>
+          </a:p>
+          <a:p>
+            <a:pPr>
+              <a:lnSpc>
+                <a:spcPct val="100000"/>
+              </a:lnSpc>
+              <a:spcAft>
+                <a:spcPts val="100"/>
               </a:spcAft>
               <a:defRPr sz="1100">
                 <a:solidFill>
@@ -3838,134 +4217,32 @@
               </a:defRPr>
             </a:pPr>
             <a:r>
-              <a:t>         │         ZMQ socket              │</a:t>
-            </a:r>
-          </a:p>
-          <a:p>
-            <a:pPr>
-              <a:spcAft>
-                <a:spcPts val="200"/>
-              </a:spcAft>
-              <a:defRPr sz="1100">
-                <a:solidFill>
-                  <a:srgbClr val="8B949E"/>
-                </a:solidFill>
-                <a:latin typeface="Consolas"/>
-              </a:defRPr>
-            </a:pPr>
-            <a:r>
-              <a:t>         │                                 ▼</a:t>
-            </a:r>
-          </a:p>
-          <a:p>
-            <a:pPr>
-              <a:spcAft>
-                <a:spcPts val="200"/>
-              </a:spcAft>
-              <a:defRPr sz="1100">
-                <a:solidFill>
-                  <a:srgbClr val="DB6D28"/>
-                </a:solidFill>
-                <a:latin typeface="Consolas"/>
-              </a:defRPr>
-            </a:pPr>
-            <a:r>
-              <a:t>         │          ┌─────────────────────────────┐</a:t>
-            </a:r>
-          </a:p>
-          <a:p>
-            <a:pPr>
-              <a:spcAft>
-                <a:spcPts val="200"/>
-              </a:spcAft>
-              <a:defRPr sz="1100">
-                <a:solidFill>
-                  <a:srgbClr val="DB6D28"/>
-                </a:solidFill>
-                <a:latin typeface="Consolas"/>
-              </a:defRPr>
-            </a:pPr>
-            <a:r>
-              <a:t>         └──────────│  Helper (gm_helper.py)      │</a:t>
-            </a:r>
-          </a:p>
-          <a:p>
-            <a:pPr>
-              <a:spcAft>
-                <a:spcPts val="200"/>
-              </a:spcAft>
-              <a:defRPr sz="1100">
-                <a:solidFill>
-                  <a:srgbClr val="C9D1D9"/>
-                </a:solidFill>
-                <a:latin typeface="Consolas"/>
-              </a:defRPr>
-            </a:pPr>
-            <a:r>
-              <a:t>                    │  • Bridge between processes │</a:t>
-            </a:r>
-          </a:p>
-          <a:p>
-            <a:pPr>
-              <a:spcAft>
-                <a:spcPts val="200"/>
-              </a:spcAft>
-              <a:defRPr sz="1100">
-                <a:solidFill>
-                  <a:srgbClr val="C9D1D9"/>
-                </a:solidFill>
-                <a:latin typeface="Consolas"/>
-              </a:defRPr>
-            </a:pPr>
-            <a:r>
-              <a:t>                    │  • Sends file paths         │</a:t>
-            </a:r>
-          </a:p>
-          <a:p>
-            <a:pPr>
-              <a:spcAft>
-                <a:spcPts val="200"/>
-              </a:spcAft>
-              <a:defRPr sz="1100">
-                <a:solidFill>
-                  <a:srgbClr val="C9D1D9"/>
-                </a:solidFill>
-                <a:latin typeface="Consolas"/>
-              </a:defRPr>
-            </a:pPr>
-            <a:r>
-              <a:t>                    │  • Waits for completion     │</a:t>
-            </a:r>
-          </a:p>
-          <a:p>
-            <a:pPr>
-              <a:spcAft>
-                <a:spcPts val="200"/>
-              </a:spcAft>
-              <a:defRPr sz="1100">
-                <a:solidFill>
-                  <a:srgbClr val="DB6D28"/>
-                </a:solidFill>
-                <a:latin typeface="Consolas"/>
-              </a:defRPr>
-            </a:pPr>
-            <a:r>
-              <a:t>                    └─────────────────────────────┘</a:t>
-            </a:r>
-          </a:p>
-          <a:p>
-            <a:pPr>
-              <a:spcAft>
-                <a:spcPts val="200"/>
-              </a:spcAft>
-              <a:defRPr sz="1100">
-                <a:solidFill>
-                  <a:srgbClr val="C9D1D9"/>
-                </a:solidFill>
-                <a:latin typeface="Consolas"/>
-              </a:defRPr>
-            </a:pPr>
-          </a:p>
+              <a:t>    └───────────────────────┘</a:t>
+            </a:r>
+          </a:p>
+        </p:txBody>
+      </p:sp>
+      <p:sp>
+        <p:nvSpPr>
+          <p:cNvPr id="8" name="TextBox 7"/>
+          <p:cNvSpPr txBox="1"/>
+          <p:nvPr/>
+        </p:nvSpPr>
+        <p:spPr>
+          <a:xfrm>
+            <a:off x="731520" y="5120640"/>
+            <a:ext cx="7315200" cy="1371600"/>
+          </a:xfrm>
+          <a:prstGeom prst="rect">
+            <a:avLst/>
+          </a:prstGeom>
+          <a:noFill/>
+        </p:spPr>
+        <p:txBody>
+          <a:bodyPr wrap="none">
+            <a:spAutoFit/>
+          </a:bodyPr>
+          <a:lstStyle/>
           <a:p>
             <a:pPr>
               <a:spcAft>

</xml_diff>

<commit_message>
Revert ZMQ diagram to single text block with bullets inside boxes
- Reverted back to single text block approach for proper alignment
- Bullet points now inside their respective boxes (not below)
- All boxes use consistent DIM color (gray) for simplicity
- Maintains proper spacing and arrow alignment
- Flow description remains at bottom
</commit_message>
<xml_diff>
--- a/presentation/test_zmq_diagrams.pptx
+++ b/presentation/test_zmq_diagrams.pptx
@@ -3684,8 +3684,8 @@
         </p:nvSpPr>
         <p:spPr>
           <a:xfrm>
-            <a:off x="731520" y="1097280"/>
-            <a:ext cx="2926080" cy="1828800"/>
+            <a:off x="457200" y="1188720"/>
+            <a:ext cx="8229600" cy="5029200"/>
           </a:xfrm>
           <a:prstGeom prst="rect">
             <a:avLst/>
@@ -3699,318 +3699,233 @@
           <a:lstStyle/>
           <a:p>
             <a:pPr>
-              <a:lnSpc>
-                <a:spcPct val="100000"/>
-              </a:lnSpc>
-              <a:spcAft>
-                <a:spcPts val="100"/>
+              <a:spcAft>
+                <a:spcPts val="200"/>
               </a:spcAft>
               <a:defRPr sz="1100">
                 <a:solidFill>
-                  <a:srgbClr val="58A6FF"/>
-                </a:solidFill>
-                <a:latin typeface="Consolas"/>
-              </a:defRPr>
-            </a:pPr>
-            <a:r>
-              <a:t>┌─────────────────────┐</a:t>
-            </a:r>
-          </a:p>
-          <a:p>
-            <a:pPr>
-              <a:lnSpc>
-                <a:spcPct val="100000"/>
-              </a:lnSpc>
-              <a:spcAft>
-                <a:spcPts val="100"/>
+                  <a:srgbClr val="8B949E"/>
+                </a:solidFill>
+                <a:latin typeface="Consolas"/>
+              </a:defRPr>
+            </a:pPr>
+            <a:r>
+              <a:t>┌─────────────────────┐        ┌─────────────────────┐</a:t>
+            </a:r>
+          </a:p>
+          <a:p>
+            <a:pPr>
+              <a:spcAft>
+                <a:spcPts val="200"/>
               </a:spcAft>
               <a:defRPr sz="1100">
                 <a:solidFill>
-                  <a:srgbClr val="58A6FF"/>
-                </a:solidFill>
-                <a:latin typeface="Consolas"/>
-              </a:defRPr>
-            </a:pPr>
-            <a:r>
-              <a:t>│  Main Process       │</a:t>
-            </a:r>
-          </a:p>
-          <a:p>
-            <a:pPr>
-              <a:lnSpc>
-                <a:spcPct val="100000"/>
-              </a:lnSpc>
-              <a:spcAft>
-                <a:spcPts val="100"/>
+                  <a:srgbClr val="8B949E"/>
+                </a:solidFill>
+                <a:latin typeface="Consolas"/>
+              </a:defRPr>
+            </a:pPr>
+            <a:r>
+              <a:t>│  Main Process       │◀──────▶│  Gaussian 16        │</a:t>
+            </a:r>
+          </a:p>
+          <a:p>
+            <a:pPr>
+              <a:spcAft>
+                <a:spcPts val="200"/>
               </a:spcAft>
               <a:defRPr sz="1100">
                 <a:solidFill>
-                  <a:srgbClr val="58A6FF"/>
-                </a:solidFill>
-                <a:latin typeface="Consolas"/>
-              </a:defRPr>
-            </a:pPr>
-            <a:r>
-              <a:t>│  (Python)           │</a:t>
-            </a:r>
-          </a:p>
-          <a:p>
-            <a:pPr>
-              <a:lnSpc>
-                <a:spcPct val="100000"/>
-              </a:lnSpc>
-              <a:spcAft>
-                <a:spcPts val="100"/>
+                  <a:srgbClr val="8B949E"/>
+                </a:solidFill>
+                <a:latin typeface="Consolas"/>
+              </a:defRPr>
+            </a:pPr>
+            <a:r>
+              <a:t>│  (Python)           │  ZMQ   │  (Fortran)          │</a:t>
+            </a:r>
+          </a:p>
+          <a:p>
+            <a:pPr>
+              <a:spcAft>
+                <a:spcPts val="200"/>
               </a:spcAft>
               <a:defRPr sz="1100">
                 <a:solidFill>
-                  <a:srgbClr val="58A6FF"/>
-                </a:solidFill>
-                <a:latin typeface="Consolas"/>
-              </a:defRPr>
-            </a:pPr>
-            <a:r>
-              <a:t>│                     │</a:t>
-            </a:r>
-          </a:p>
-          <a:p>
-            <a:pPr>
-              <a:lnSpc>
-                <a:spcPct val="100000"/>
-              </a:lnSpc>
-              <a:spcAft>
-                <a:spcPts val="100"/>
+                  <a:srgbClr val="8B949E"/>
+                </a:solidFill>
+                <a:latin typeface="Consolas"/>
+              </a:defRPr>
+            </a:pPr>
+            <a:r>
+              <a:t>│                     │        │                     │</a:t>
+            </a:r>
+          </a:p>
+          <a:p>
+            <a:pPr>
+              <a:spcAft>
+                <a:spcPts val="200"/>
               </a:spcAft>
               <a:defRPr sz="1100">
                 <a:solidFill>
-                  <a:srgbClr val="58A6FF"/>
-                </a:solidFill>
-                <a:latin typeface="Consolas"/>
-              </a:defRPr>
-            </a:pPr>
-            <a:r>
-              <a:t>│  • ZMQ server       │</a:t>
-            </a:r>
-          </a:p>
-          <a:p>
-            <a:pPr>
-              <a:lnSpc>
-                <a:spcPct val="100000"/>
-              </a:lnSpc>
-              <a:spcAft>
-                <a:spcPts val="100"/>
+                  <a:srgbClr val="8B949E"/>
+                </a:solidFill>
+                <a:latin typeface="Consolas"/>
+              </a:defRPr>
+            </a:pPr>
+            <a:r>
+              <a:t>│  • ZMQ server       │        │  • Freq calculation │</a:t>
+            </a:r>
+          </a:p>
+          <a:p>
+            <a:pPr>
+              <a:spcAft>
+                <a:spcPts val="200"/>
               </a:spcAft>
               <a:defRPr sz="1100">
                 <a:solidFill>
-                  <a:srgbClr val="58A6FF"/>
-                </a:solidFill>
-                <a:latin typeface="Consolas"/>
-              </a:defRPr>
-            </a:pPr>
-            <a:r>
-              <a:t>│  • ML dipole calc   │</a:t>
-            </a:r>
-          </a:p>
-          <a:p>
-            <a:pPr>
-              <a:lnSpc>
-                <a:spcPct val="100000"/>
-              </a:lnSpc>
-              <a:spcAft>
-                <a:spcPts val="100"/>
+                  <a:srgbClr val="8B949E"/>
+                </a:solidFill>
+                <a:latin typeface="Consolas"/>
+              </a:defRPr>
+            </a:pPr>
+            <a:r>
+              <a:t>│  • ML dipole calc   │        │  • Calls external   │</a:t>
+            </a:r>
+          </a:p>
+          <a:p>
+            <a:pPr>
+              <a:spcAft>
+                <a:spcPts val="200"/>
               </a:spcAft>
               <a:defRPr sz="1100">
                 <a:solidFill>
-                  <a:srgbClr val="58A6FF"/>
-                </a:solidFill>
-                <a:latin typeface="Consolas"/>
-              </a:defRPr>
-            </a:pPr>
-            <a:r>
-              <a:t>└─────────────────────┘</a:t>
-            </a:r>
-          </a:p>
-        </p:txBody>
-      </p:sp>
-      <p:sp>
-        <p:nvSpPr>
-          <p:cNvPr id="4" name="TextBox 3"/>
-          <p:cNvSpPr txBox="1"/>
-          <p:nvPr/>
-        </p:nvSpPr>
-        <p:spPr>
-          <a:xfrm>
-            <a:off x="5303520" y="1097280"/>
-            <a:ext cx="2926080" cy="1828800"/>
-          </a:xfrm>
-          <a:prstGeom prst="rect">
-            <a:avLst/>
-          </a:prstGeom>
-          <a:noFill/>
-        </p:spPr>
-        <p:txBody>
-          <a:bodyPr wrap="none">
-            <a:spAutoFit/>
-          </a:bodyPr>
-          <a:lstStyle/>
-          <a:p>
-            <a:pPr>
-              <a:lnSpc>
-                <a:spcPct val="100000"/>
-              </a:lnSpc>
-              <a:spcAft>
-                <a:spcPts val="100"/>
+                  <a:srgbClr val="8B949E"/>
+                </a:solidFill>
+                <a:latin typeface="Consolas"/>
+              </a:defRPr>
+            </a:pPr>
+            <a:r>
+              <a:t>└─────────────────────┘        └─────────────────────┘</a:t>
+            </a:r>
+          </a:p>
+          <a:p>
+            <a:pPr>
+              <a:spcAft>
+                <a:spcPts val="200"/>
               </a:spcAft>
               <a:defRPr sz="1100">
                 <a:solidFill>
-                  <a:srgbClr val="57AB5A"/>
-                </a:solidFill>
-                <a:latin typeface="Consolas"/>
-              </a:defRPr>
-            </a:pPr>
-            <a:r>
-              <a:t>┌─────────────────────┐</a:t>
-            </a:r>
-          </a:p>
-          <a:p>
-            <a:pPr>
-              <a:lnSpc>
-                <a:spcPct val="100000"/>
-              </a:lnSpc>
-              <a:spcAft>
-                <a:spcPts val="100"/>
+                  <a:srgbClr val="8B949E"/>
+                </a:solidFill>
+                <a:latin typeface="Consolas"/>
+              </a:defRPr>
+            </a:pPr>
+            <a:r>
+              <a:t>         ▲                                 │</a:t>
+            </a:r>
+          </a:p>
+          <a:p>
+            <a:pPr>
+              <a:spcAft>
+                <a:spcPts val="200"/>
               </a:spcAft>
               <a:defRPr sz="1100">
                 <a:solidFill>
-                  <a:srgbClr val="57AB5A"/>
-                </a:solidFill>
-                <a:latin typeface="Consolas"/>
-              </a:defRPr>
-            </a:pPr>
-            <a:r>
-              <a:t>│  Gaussian 16        │</a:t>
-            </a:r>
-          </a:p>
-          <a:p>
-            <a:pPr>
-              <a:lnSpc>
-                <a:spcPct val="100000"/>
-              </a:lnSpc>
-              <a:spcAft>
-                <a:spcPts val="100"/>
+                  <a:srgbClr val="8B949E"/>
+                </a:solidFill>
+                <a:latin typeface="Consolas"/>
+              </a:defRPr>
+            </a:pPr>
+            <a:r>
+              <a:t>         │                                 │</a:t>
+            </a:r>
+          </a:p>
+          <a:p>
+            <a:pPr>
+              <a:spcAft>
+                <a:spcPts val="200"/>
               </a:spcAft>
               <a:defRPr sz="1100">
                 <a:solidFill>
-                  <a:srgbClr val="57AB5A"/>
-                </a:solidFill>
-                <a:latin typeface="Consolas"/>
-              </a:defRPr>
-            </a:pPr>
-            <a:r>
-              <a:t>│  (Fortran)          │</a:t>
-            </a:r>
-          </a:p>
-          <a:p>
-            <a:pPr>
-              <a:lnSpc>
-                <a:spcPct val="100000"/>
-              </a:lnSpc>
-              <a:spcAft>
-                <a:spcPts val="100"/>
+                  <a:srgbClr val="8B949E"/>
+                </a:solidFill>
+                <a:latin typeface="Consolas"/>
+              </a:defRPr>
+            </a:pPr>
+            <a:r>
+              <a:t>         │         ZMQ socket              │</a:t>
+            </a:r>
+          </a:p>
+          <a:p>
+            <a:pPr>
+              <a:spcAft>
+                <a:spcPts val="200"/>
               </a:spcAft>
               <a:defRPr sz="1100">
                 <a:solidFill>
-                  <a:srgbClr val="57AB5A"/>
-                </a:solidFill>
-                <a:latin typeface="Consolas"/>
-              </a:defRPr>
-            </a:pPr>
-            <a:r>
-              <a:t>│                     │</a:t>
-            </a:r>
-          </a:p>
-          <a:p>
-            <a:pPr>
-              <a:lnSpc>
-                <a:spcPct val="100000"/>
-              </a:lnSpc>
-              <a:spcAft>
-                <a:spcPts val="100"/>
+                  <a:srgbClr val="8B949E"/>
+                </a:solidFill>
+                <a:latin typeface="Consolas"/>
+              </a:defRPr>
+            </a:pPr>
+            <a:r>
+              <a:t>         │                                 ▼</a:t>
+            </a:r>
+          </a:p>
+          <a:p>
+            <a:pPr>
+              <a:spcAft>
+                <a:spcPts val="200"/>
               </a:spcAft>
               <a:defRPr sz="1100">
                 <a:solidFill>
-                  <a:srgbClr val="57AB5A"/>
-                </a:solidFill>
-                <a:latin typeface="Consolas"/>
-              </a:defRPr>
-            </a:pPr>
-            <a:r>
-              <a:t>│  • Freq calculation │</a:t>
-            </a:r>
-          </a:p>
-          <a:p>
-            <a:pPr>
-              <a:lnSpc>
-                <a:spcPct val="100000"/>
-              </a:lnSpc>
-              <a:spcAft>
-                <a:spcPts val="100"/>
+                  <a:srgbClr val="8B949E"/>
+                </a:solidFill>
+                <a:latin typeface="Consolas"/>
+              </a:defRPr>
+            </a:pPr>
+            <a:r>
+              <a:t>         │          ┌─────────────────────────────┐</a:t>
+            </a:r>
+          </a:p>
+          <a:p>
+            <a:pPr>
+              <a:spcAft>
+                <a:spcPts val="200"/>
               </a:spcAft>
               <a:defRPr sz="1100">
                 <a:solidFill>
-                  <a:srgbClr val="57AB5A"/>
-                </a:solidFill>
-                <a:latin typeface="Consolas"/>
-              </a:defRPr>
-            </a:pPr>
-            <a:r>
-              <a:t>│  • Calls external   │</a:t>
-            </a:r>
-          </a:p>
-          <a:p>
-            <a:pPr>
-              <a:lnSpc>
-                <a:spcPct val="100000"/>
-              </a:lnSpc>
-              <a:spcAft>
-                <a:spcPts val="100"/>
+                  <a:srgbClr val="8B949E"/>
+                </a:solidFill>
+                <a:latin typeface="Consolas"/>
+              </a:defRPr>
+            </a:pPr>
+            <a:r>
+              <a:t>         └──────────│  Helper (gm_helper.py)      │</a:t>
+            </a:r>
+          </a:p>
+          <a:p>
+            <a:pPr>
+              <a:spcAft>
+                <a:spcPts val="200"/>
               </a:spcAft>
               <a:defRPr sz="1100">
                 <a:solidFill>
-                  <a:srgbClr val="57AB5A"/>
-                </a:solidFill>
-                <a:latin typeface="Consolas"/>
-              </a:defRPr>
-            </a:pPr>
-            <a:r>
-              <a:t>└─────────────────────┘</a:t>
-            </a:r>
-          </a:p>
-        </p:txBody>
-      </p:sp>
-      <p:sp>
-        <p:nvSpPr>
-          <p:cNvPr id="5" name="TextBox 4"/>
-          <p:cNvSpPr txBox="1"/>
-          <p:nvPr/>
-        </p:nvSpPr>
-        <p:spPr>
-          <a:xfrm>
-            <a:off x="3657600" y="1828800"/>
-            <a:ext cx="1645920" cy="365760"/>
-          </a:xfrm>
-          <a:prstGeom prst="rect">
-            <a:avLst/>
-          </a:prstGeom>
-          <a:noFill/>
-        </p:spPr>
-        <p:txBody>
-          <a:bodyPr wrap="none">
-            <a:spAutoFit/>
-          </a:bodyPr>
-          <a:lstStyle/>
-          <a:p>
-            <a:pPr algn="ctr">
+                  <a:srgbClr val="8B949E"/>
+                </a:solidFill>
+                <a:latin typeface="Consolas"/>
+              </a:defRPr>
+            </a:pPr>
+            <a:r>
+              <a:t>                    │  • Bridge between processes │</a:t>
+            </a:r>
+          </a:p>
+          <a:p>
+            <a:pPr>
+              <a:spcAft>
+                <a:spcPts val="200"/>
+              </a:spcAft>
               <a:defRPr sz="1100">
                 <a:solidFill>
                   <a:srgbClr val="8B949E"/>
@@ -4019,230 +3934,54 @@
               </a:defRPr>
             </a:pPr>
             <a:r>
-              <a:t>◀──ZMQ──▶</a:t>
-            </a:r>
-          </a:p>
-        </p:txBody>
-      </p:sp>
-      <p:sp>
-        <p:nvSpPr>
-          <p:cNvPr id="6" name="TextBox 5"/>
-          <p:cNvSpPr txBox="1"/>
-          <p:nvPr/>
-        </p:nvSpPr>
-        <p:spPr>
-          <a:xfrm>
-            <a:off x="2743200" y="3474720"/>
-            <a:ext cx="3840480" cy="1463040"/>
-          </a:xfrm>
-          <a:prstGeom prst="rect">
-            <a:avLst/>
-          </a:prstGeom>
-          <a:noFill/>
-        </p:spPr>
-        <p:txBody>
-          <a:bodyPr wrap="none">
-            <a:spAutoFit/>
-          </a:bodyPr>
-          <a:lstStyle/>
-          <a:p>
-            <a:pPr>
-              <a:lnSpc>
-                <a:spcPct val="100000"/>
-              </a:lnSpc>
-              <a:spcAft>
-                <a:spcPts val="100"/>
+              <a:t>                    │  • Sends file paths         │</a:t>
+            </a:r>
+          </a:p>
+          <a:p>
+            <a:pPr>
+              <a:spcAft>
+                <a:spcPts val="200"/>
               </a:spcAft>
               <a:defRPr sz="1100">
                 <a:solidFill>
-                  <a:srgbClr val="DB6D28"/>
-                </a:solidFill>
-                <a:latin typeface="Consolas"/>
-              </a:defRPr>
-            </a:pPr>
-            <a:r>
-              <a:t>┌─────────────────────────────┐</a:t>
-            </a:r>
-          </a:p>
-          <a:p>
-            <a:pPr>
-              <a:lnSpc>
-                <a:spcPct val="100000"/>
-              </a:lnSpc>
-              <a:spcAft>
-                <a:spcPts val="100"/>
+                  <a:srgbClr val="8B949E"/>
+                </a:solidFill>
+                <a:latin typeface="Consolas"/>
+              </a:defRPr>
+            </a:pPr>
+            <a:r>
+              <a:t>                    │  • Waits for completion     │</a:t>
+            </a:r>
+          </a:p>
+          <a:p>
+            <a:pPr>
+              <a:spcAft>
+                <a:spcPts val="200"/>
               </a:spcAft>
               <a:defRPr sz="1100">
                 <a:solidFill>
-                  <a:srgbClr val="DB6D28"/>
-                </a:solidFill>
-                <a:latin typeface="Consolas"/>
-              </a:defRPr>
-            </a:pPr>
-            <a:r>
-              <a:t>│  Helper (gm_helper.py)      │</a:t>
-            </a:r>
-          </a:p>
-          <a:p>
-            <a:pPr>
-              <a:lnSpc>
-                <a:spcPct val="100000"/>
-              </a:lnSpc>
-              <a:spcAft>
-                <a:spcPts val="100"/>
+                  <a:srgbClr val="8B949E"/>
+                </a:solidFill>
+                <a:latin typeface="Consolas"/>
+              </a:defRPr>
+            </a:pPr>
+            <a:r>
+              <a:t>                    └─────────────────────────────┘</a:t>
+            </a:r>
+          </a:p>
+          <a:p>
+            <a:pPr>
+              <a:spcAft>
+                <a:spcPts val="200"/>
               </a:spcAft>
               <a:defRPr sz="1100">
                 <a:solidFill>
-                  <a:srgbClr val="DB6D28"/>
-                </a:solidFill>
-                <a:latin typeface="Consolas"/>
-              </a:defRPr>
-            </a:pPr>
-            <a:r>
-              <a:t>│  • Bridge between processes │</a:t>
-            </a:r>
-          </a:p>
-          <a:p>
-            <a:pPr>
-              <a:lnSpc>
-                <a:spcPct val="100000"/>
-              </a:lnSpc>
-              <a:spcAft>
-                <a:spcPts val="100"/>
-              </a:spcAft>
-              <a:defRPr sz="1100">
-                <a:solidFill>
-                  <a:srgbClr val="DB6D28"/>
-                </a:solidFill>
-                <a:latin typeface="Consolas"/>
-              </a:defRPr>
-            </a:pPr>
-            <a:r>
-              <a:t>│  • Sends file paths         │</a:t>
-            </a:r>
-          </a:p>
-          <a:p>
-            <a:pPr>
-              <a:lnSpc>
-                <a:spcPct val="100000"/>
-              </a:lnSpc>
-              <a:spcAft>
-                <a:spcPts val="100"/>
-              </a:spcAft>
-              <a:defRPr sz="1100">
-                <a:solidFill>
-                  <a:srgbClr val="DB6D28"/>
-                </a:solidFill>
-                <a:latin typeface="Consolas"/>
-              </a:defRPr>
-            </a:pPr>
-            <a:r>
-              <a:t>│  • Waits for completion     │</a:t>
-            </a:r>
-          </a:p>
-          <a:p>
-            <a:pPr>
-              <a:lnSpc>
-                <a:spcPct val="100000"/>
-              </a:lnSpc>
-              <a:spcAft>
-                <a:spcPts val="100"/>
-              </a:spcAft>
-              <a:defRPr sz="1100">
-                <a:solidFill>
-                  <a:srgbClr val="DB6D28"/>
-                </a:solidFill>
-                <a:latin typeface="Consolas"/>
-              </a:defRPr>
-            </a:pPr>
-            <a:r>
-              <a:t>└─────────────────────────────┘</a:t>
-            </a:r>
-          </a:p>
-        </p:txBody>
-      </p:sp>
-      <p:sp>
-        <p:nvSpPr>
-          <p:cNvPr id="7" name="TextBox 6"/>
-          <p:cNvSpPr txBox="1"/>
-          <p:nvPr/>
-        </p:nvSpPr>
-        <p:spPr>
-          <a:xfrm>
-            <a:off x="1371600" y="3017520"/>
-            <a:ext cx="5943600" cy="548640"/>
-          </a:xfrm>
-          <a:prstGeom prst="rect">
-            <a:avLst/>
-          </a:prstGeom>
-          <a:noFill/>
-        </p:spPr>
-        <p:txBody>
-          <a:bodyPr wrap="none">
-            <a:spAutoFit/>
-          </a:bodyPr>
-          <a:lstStyle/>
-          <a:p>
-            <a:pPr>
-              <a:lnSpc>
-                <a:spcPct val="100000"/>
-              </a:lnSpc>
-              <a:spcAft>
-                <a:spcPts val="100"/>
-              </a:spcAft>
-              <a:defRPr sz="1100">
-                <a:solidFill>
-                  <a:srgbClr val="8B949E"/>
-                </a:solidFill>
-                <a:latin typeface="Consolas"/>
-              </a:defRPr>
-            </a:pPr>
-            <a:r>
-              <a:t>    ▲                       │</a:t>
-            </a:r>
-          </a:p>
-          <a:p>
-            <a:pPr>
-              <a:lnSpc>
-                <a:spcPct val="100000"/>
-              </a:lnSpc>
-              <a:spcAft>
-                <a:spcPts val="100"/>
-              </a:spcAft>
-              <a:defRPr sz="1100">
-                <a:solidFill>
-                  <a:srgbClr val="8B949E"/>
-                </a:solidFill>
-                <a:latin typeface="Consolas"/>
-              </a:defRPr>
-            </a:pPr>
-            <a:r>
-              <a:t>    └───────────────────────┘</a:t>
-            </a:r>
-          </a:p>
-        </p:txBody>
-      </p:sp>
-      <p:sp>
-        <p:nvSpPr>
-          <p:cNvPr id="8" name="TextBox 7"/>
-          <p:cNvSpPr txBox="1"/>
-          <p:nvPr/>
-        </p:nvSpPr>
-        <p:spPr>
-          <a:xfrm>
-            <a:off x="731520" y="5120640"/>
-            <a:ext cx="7315200" cy="1371600"/>
-          </a:xfrm>
-          <a:prstGeom prst="rect">
-            <a:avLst/>
-          </a:prstGeom>
-          <a:noFill/>
-        </p:spPr>
-        <p:txBody>
-          <a:bodyPr wrap="none">
-            <a:spAutoFit/>
-          </a:bodyPr>
-          <a:lstStyle/>
+                  <a:srgbClr val="C9D1D9"/>
+                </a:solidFill>
+                <a:latin typeface="Consolas"/>
+              </a:defRPr>
+            </a:pPr>
+          </a:p>
           <a:p>
             <a:pPr>
               <a:spcAft>

</xml_diff>

<commit_message>
Add color coding to ZMQ side-by-side diagram
- Top boxes (Main Process & Gaussian): ACCENT (blue)
- Helper box: ORANGE
- Arrows/connectors: DIM (gray)
- Bullet points inside boxes remain part of box color
- Flow description uses ACCENT header + TEXT content
</commit_message>
<xml_diff>
--- a/presentation/test_zmq_diagrams.pptx
+++ b/presentation/test_zmq_diagrams.pptx
@@ -3704,13 +3704,125 @@
               </a:spcAft>
               <a:defRPr sz="1100">
                 <a:solidFill>
+                  <a:srgbClr val="58A6FF"/>
+                </a:solidFill>
+                <a:latin typeface="Consolas"/>
+              </a:defRPr>
+            </a:pPr>
+            <a:r>
+              <a:t>┌─────────────────────┐        ┌─────────────────────┐</a:t>
+            </a:r>
+          </a:p>
+          <a:p>
+            <a:pPr>
+              <a:spcAft>
+                <a:spcPts val="200"/>
+              </a:spcAft>
+              <a:defRPr sz="1100">
+                <a:solidFill>
+                  <a:srgbClr val="58A6FF"/>
+                </a:solidFill>
+                <a:latin typeface="Consolas"/>
+              </a:defRPr>
+            </a:pPr>
+            <a:r>
+              <a:t>│  Main Process       │◀──────▶│  Gaussian 16        │</a:t>
+            </a:r>
+          </a:p>
+          <a:p>
+            <a:pPr>
+              <a:spcAft>
+                <a:spcPts val="200"/>
+              </a:spcAft>
+              <a:defRPr sz="1100">
+                <a:solidFill>
+                  <a:srgbClr val="58A6FF"/>
+                </a:solidFill>
+                <a:latin typeface="Consolas"/>
+              </a:defRPr>
+            </a:pPr>
+            <a:r>
+              <a:t>│  (Python)           │  ZMQ   │  (Fortran)          │</a:t>
+            </a:r>
+          </a:p>
+          <a:p>
+            <a:pPr>
+              <a:spcAft>
+                <a:spcPts val="200"/>
+              </a:spcAft>
+              <a:defRPr sz="1100">
+                <a:solidFill>
+                  <a:srgbClr val="58A6FF"/>
+                </a:solidFill>
+                <a:latin typeface="Consolas"/>
+              </a:defRPr>
+            </a:pPr>
+            <a:r>
+              <a:t>│                     │        │                     │</a:t>
+            </a:r>
+          </a:p>
+          <a:p>
+            <a:pPr>
+              <a:spcAft>
+                <a:spcPts val="200"/>
+              </a:spcAft>
+              <a:defRPr sz="1100">
+                <a:solidFill>
+                  <a:srgbClr val="58A6FF"/>
+                </a:solidFill>
+                <a:latin typeface="Consolas"/>
+              </a:defRPr>
+            </a:pPr>
+            <a:r>
+              <a:t>│  • ZMQ server       │        │  • Freq calculation │</a:t>
+            </a:r>
+          </a:p>
+          <a:p>
+            <a:pPr>
+              <a:spcAft>
+                <a:spcPts val="200"/>
+              </a:spcAft>
+              <a:defRPr sz="1100">
+                <a:solidFill>
+                  <a:srgbClr val="58A6FF"/>
+                </a:solidFill>
+                <a:latin typeface="Consolas"/>
+              </a:defRPr>
+            </a:pPr>
+            <a:r>
+              <a:t>│  • ML dipole calc   │        │  • Calls external   │</a:t>
+            </a:r>
+          </a:p>
+          <a:p>
+            <a:pPr>
+              <a:spcAft>
+                <a:spcPts val="200"/>
+              </a:spcAft>
+              <a:defRPr sz="1100">
+                <a:solidFill>
+                  <a:srgbClr val="58A6FF"/>
+                </a:solidFill>
+                <a:latin typeface="Consolas"/>
+              </a:defRPr>
+            </a:pPr>
+            <a:r>
+              <a:t>└─────────────────────┘        └─────────────────────┘</a:t>
+            </a:r>
+          </a:p>
+          <a:p>
+            <a:pPr>
+              <a:spcAft>
+                <a:spcPts val="200"/>
+              </a:spcAft>
+              <a:defRPr sz="1100">
+                <a:solidFill>
                   <a:srgbClr val="8B949E"/>
                 </a:solidFill>
                 <a:latin typeface="Consolas"/>
               </a:defRPr>
             </a:pPr>
             <a:r>
-              <a:t>┌─────────────────────┐        ┌─────────────────────┐</a:t>
+              <a:t>         ▲                                 │</a:t>
             </a:r>
           </a:p>
           <a:p>
@@ -3726,7 +3838,7 @@
               </a:defRPr>
             </a:pPr>
             <a:r>
-              <a:t>│  Main Process       │◀──────▶│  Gaussian 16        │</a:t>
+              <a:t>         │                                 │</a:t>
             </a:r>
           </a:p>
           <a:p>
@@ -3742,7 +3854,7 @@
               </a:defRPr>
             </a:pPr>
             <a:r>
-              <a:t>│  (Python)           │  ZMQ   │  (Fortran)          │</a:t>
+              <a:t>         │         ZMQ socket              │</a:t>
             </a:r>
           </a:p>
           <a:p>
@@ -3758,7 +3870,7 @@
               </a:defRPr>
             </a:pPr>
             <a:r>
-              <a:t>│                     │        │                     │</a:t>
+              <a:t>         │                                 ▼</a:t>
             </a:r>
           </a:p>
           <a:p>
@@ -3768,13 +3880,13 @@
               </a:spcAft>
               <a:defRPr sz="1100">
                 <a:solidFill>
-                  <a:srgbClr val="8B949E"/>
-                </a:solidFill>
-                <a:latin typeface="Consolas"/>
-              </a:defRPr>
-            </a:pPr>
-            <a:r>
-              <a:t>│  • ZMQ server       │        │  • Freq calculation │</a:t>
+                  <a:srgbClr val="DB6D28"/>
+                </a:solidFill>
+                <a:latin typeface="Consolas"/>
+              </a:defRPr>
+            </a:pPr>
+            <a:r>
+              <a:t>         │          ┌─────────────────────────────┐</a:t>
             </a:r>
           </a:p>
           <a:p>
@@ -3784,13 +3896,13 @@
               </a:spcAft>
               <a:defRPr sz="1100">
                 <a:solidFill>
-                  <a:srgbClr val="8B949E"/>
-                </a:solidFill>
-                <a:latin typeface="Consolas"/>
-              </a:defRPr>
-            </a:pPr>
-            <a:r>
-              <a:t>│  • ML dipole calc   │        │  • Calls external   │</a:t>
+                  <a:srgbClr val="DB6D28"/>
+                </a:solidFill>
+                <a:latin typeface="Consolas"/>
+              </a:defRPr>
+            </a:pPr>
+            <a:r>
+              <a:t>         └──────────│  Helper (gm_helper.py)      │</a:t>
             </a:r>
           </a:p>
           <a:p>
@@ -3800,13 +3912,13 @@
               </a:spcAft>
               <a:defRPr sz="1100">
                 <a:solidFill>
-                  <a:srgbClr val="8B949E"/>
-                </a:solidFill>
-                <a:latin typeface="Consolas"/>
-              </a:defRPr>
-            </a:pPr>
-            <a:r>
-              <a:t>└─────────────────────┘        └─────────────────────┘</a:t>
+                  <a:srgbClr val="DB6D28"/>
+                </a:solidFill>
+                <a:latin typeface="Consolas"/>
+              </a:defRPr>
+            </a:pPr>
+            <a:r>
+              <a:t>                    │  • Bridge between processes │</a:t>
             </a:r>
           </a:p>
           <a:p>
@@ -3816,13 +3928,13 @@
               </a:spcAft>
               <a:defRPr sz="1100">
                 <a:solidFill>
-                  <a:srgbClr val="8B949E"/>
-                </a:solidFill>
-                <a:latin typeface="Consolas"/>
-              </a:defRPr>
-            </a:pPr>
-            <a:r>
-              <a:t>         ▲                                 │</a:t>
+                  <a:srgbClr val="DB6D28"/>
+                </a:solidFill>
+                <a:latin typeface="Consolas"/>
+              </a:defRPr>
+            </a:pPr>
+            <a:r>
+              <a:t>                    │  • Sends file paths         │</a:t>
             </a:r>
           </a:p>
           <a:p>
@@ -3832,13 +3944,13 @@
               </a:spcAft>
               <a:defRPr sz="1100">
                 <a:solidFill>
-                  <a:srgbClr val="8B949E"/>
-                </a:solidFill>
-                <a:latin typeface="Consolas"/>
-              </a:defRPr>
-            </a:pPr>
-            <a:r>
-              <a:t>         │                                 │</a:t>
+                  <a:srgbClr val="DB6D28"/>
+                </a:solidFill>
+                <a:latin typeface="Consolas"/>
+              </a:defRPr>
+            </a:pPr>
+            <a:r>
+              <a:t>                    │  • Waits for completion     │</a:t>
             </a:r>
           </a:p>
           <a:p>
@@ -3848,119 +3960,7 @@
               </a:spcAft>
               <a:defRPr sz="1100">
                 <a:solidFill>
-                  <a:srgbClr val="8B949E"/>
-                </a:solidFill>
-                <a:latin typeface="Consolas"/>
-              </a:defRPr>
-            </a:pPr>
-            <a:r>
-              <a:t>         │         ZMQ socket              │</a:t>
-            </a:r>
-          </a:p>
-          <a:p>
-            <a:pPr>
-              <a:spcAft>
-                <a:spcPts val="200"/>
-              </a:spcAft>
-              <a:defRPr sz="1100">
-                <a:solidFill>
-                  <a:srgbClr val="8B949E"/>
-                </a:solidFill>
-                <a:latin typeface="Consolas"/>
-              </a:defRPr>
-            </a:pPr>
-            <a:r>
-              <a:t>         │                                 ▼</a:t>
-            </a:r>
-          </a:p>
-          <a:p>
-            <a:pPr>
-              <a:spcAft>
-                <a:spcPts val="200"/>
-              </a:spcAft>
-              <a:defRPr sz="1100">
-                <a:solidFill>
-                  <a:srgbClr val="8B949E"/>
-                </a:solidFill>
-                <a:latin typeface="Consolas"/>
-              </a:defRPr>
-            </a:pPr>
-            <a:r>
-              <a:t>         │          ┌─────────────────────────────┐</a:t>
-            </a:r>
-          </a:p>
-          <a:p>
-            <a:pPr>
-              <a:spcAft>
-                <a:spcPts val="200"/>
-              </a:spcAft>
-              <a:defRPr sz="1100">
-                <a:solidFill>
-                  <a:srgbClr val="8B949E"/>
-                </a:solidFill>
-                <a:latin typeface="Consolas"/>
-              </a:defRPr>
-            </a:pPr>
-            <a:r>
-              <a:t>         └──────────│  Helper (gm_helper.py)      │</a:t>
-            </a:r>
-          </a:p>
-          <a:p>
-            <a:pPr>
-              <a:spcAft>
-                <a:spcPts val="200"/>
-              </a:spcAft>
-              <a:defRPr sz="1100">
-                <a:solidFill>
-                  <a:srgbClr val="8B949E"/>
-                </a:solidFill>
-                <a:latin typeface="Consolas"/>
-              </a:defRPr>
-            </a:pPr>
-            <a:r>
-              <a:t>                    │  • Bridge between processes │</a:t>
-            </a:r>
-          </a:p>
-          <a:p>
-            <a:pPr>
-              <a:spcAft>
-                <a:spcPts val="200"/>
-              </a:spcAft>
-              <a:defRPr sz="1100">
-                <a:solidFill>
-                  <a:srgbClr val="8B949E"/>
-                </a:solidFill>
-                <a:latin typeface="Consolas"/>
-              </a:defRPr>
-            </a:pPr>
-            <a:r>
-              <a:t>                    │  • Sends file paths         │</a:t>
-            </a:r>
-          </a:p>
-          <a:p>
-            <a:pPr>
-              <a:spcAft>
-                <a:spcPts val="200"/>
-              </a:spcAft>
-              <a:defRPr sz="1100">
-                <a:solidFill>
-                  <a:srgbClr val="8B949E"/>
-                </a:solidFill>
-                <a:latin typeface="Consolas"/>
-              </a:defRPr>
-            </a:pPr>
-            <a:r>
-              <a:t>                    │  • Waits for completion     │</a:t>
-            </a:r>
-          </a:p>
-          <a:p>
-            <a:pPr>
-              <a:spcAft>
-                <a:spcPts val="200"/>
-              </a:spcAft>
-              <a:defRPr sz="1100">
-                <a:solidFill>
-                  <a:srgbClr val="8B949E"/>
+                  <a:srgbClr val="DB6D28"/>
                 </a:solidFill>
                 <a:latin typeface="Consolas"/>
               </a:defRPr>

</xml_diff>

<commit_message>
Add return arrow from Helper to Gaussian in ZMQ diagram
Completes the communication cycle:
1. Gaussian → Helper (calls external)
2. Helper → Main (ZMQ connection)
3. Main → Helper ("done" signal via ZMQ)
4. Helper → Gaussian (return - NEW ARROW)

Now shows complete bidirectional flow
</commit_message>
<xml_diff>
--- a/presentation/test_zmq_diagrams.pptx
+++ b/presentation/test_zmq_diagrams.pptx
@@ -3902,7 +3902,7 @@
               </a:defRPr>
             </a:pPr>
             <a:r>
-              <a:t>         └──────────│  Helper (gm_helper.py)      │</a:t>
+              <a:t>         └──────────│  Helper (gm_helper.py)      │──────────┐</a:t>
             </a:r>
           </a:p>
           <a:p>
@@ -3918,7 +3918,7 @@
               </a:defRPr>
             </a:pPr>
             <a:r>
-              <a:t>                    │  • Bridge between processes │</a:t>
+              <a:t>                    │  • Bridge between processes │          │</a:t>
             </a:r>
           </a:p>
           <a:p>
@@ -3934,7 +3934,7 @@
               </a:defRPr>
             </a:pPr>
             <a:r>
-              <a:t>                    │  • Sends file paths         │</a:t>
+              <a:t>                    │  • Sends file paths         │          │</a:t>
             </a:r>
           </a:p>
           <a:p>
@@ -3950,7 +3950,7 @@
               </a:defRPr>
             </a:pPr>
             <a:r>
-              <a:t>                    │  • Waits for completion     │</a:t>
+              <a:t>                    │  • Waits for completion     │          │</a:t>
             </a:r>
           </a:p>
           <a:p>
@@ -3966,7 +3966,39 @@
               </a:defRPr>
             </a:pPr>
             <a:r>
-              <a:t>                    └─────────────────────────────┘</a:t>
+              <a:t>                    └─────────────────────────────┘          │</a:t>
+            </a:r>
+          </a:p>
+          <a:p>
+            <a:pPr>
+              <a:spcAft>
+                <a:spcPts val="200"/>
+              </a:spcAft>
+              <a:defRPr sz="1100">
+                <a:solidFill>
+                  <a:srgbClr val="8B949E"/>
+                </a:solidFill>
+                <a:latin typeface="Consolas"/>
+              </a:defRPr>
+            </a:pPr>
+            <a:r>
+              <a:t>                                                              │</a:t>
+            </a:r>
+          </a:p>
+          <a:p>
+            <a:pPr>
+              <a:spcAft>
+                <a:spcPts val="200"/>
+              </a:spcAft>
+              <a:defRPr sz="1100">
+                <a:solidFill>
+                  <a:srgbClr val="8B949E"/>
+                </a:solidFill>
+                <a:latin typeface="Consolas"/>
+              </a:defRPr>
+            </a:pPr>
+            <a:r>
+              <a:t>                                                              └──▶</a:t>
             </a:r>
           </a:p>
           <a:p>

</xml_diff>

<commit_message>
Simplify ZMQ diagram: add upward return arrow from Helper to Gaussian
</commit_message>
<xml_diff>
--- a/presentation/test_zmq_diagrams.pptx
+++ b/presentation/test_zmq_diagrams.pptx
@@ -3822,7 +3822,7 @@
               </a:defRPr>
             </a:pPr>
             <a:r>
-              <a:t>         ▲                                 │</a:t>
+              <a:t>         ▲                                 │          ▲</a:t>
             </a:r>
           </a:p>
           <a:p>
@@ -3838,7 +3838,7 @@
               </a:defRPr>
             </a:pPr>
             <a:r>
-              <a:t>         │                                 │</a:t>
+              <a:t>         │                                 │          │</a:t>
             </a:r>
           </a:p>
           <a:p>
@@ -3854,7 +3854,7 @@
               </a:defRPr>
             </a:pPr>
             <a:r>
-              <a:t>         │         ZMQ socket              │</a:t>
+              <a:t>         │         ZMQ socket              │          │</a:t>
             </a:r>
           </a:p>
           <a:p>
@@ -3870,7 +3870,7 @@
               </a:defRPr>
             </a:pPr>
             <a:r>
-              <a:t>         │                                 ▼</a:t>
+              <a:t>         │                                 ▼          │</a:t>
             </a:r>
           </a:p>
           <a:p>
@@ -3886,7 +3886,7 @@
               </a:defRPr>
             </a:pPr>
             <a:r>
-              <a:t>         │          ┌─────────────────────────────┐</a:t>
+              <a:t>         │          ┌─────────────────────────────┐  │</a:t>
             </a:r>
           </a:p>
           <a:p>
@@ -3902,7 +3902,7 @@
               </a:defRPr>
             </a:pPr>
             <a:r>
-              <a:t>         └──────────│  Helper (gm_helper.py)      │──────────┐</a:t>
+              <a:t>         └──────────│  Helper (gm_helper.py)      │──┘</a:t>
             </a:r>
           </a:p>
           <a:p>
@@ -3918,7 +3918,7 @@
               </a:defRPr>
             </a:pPr>
             <a:r>
-              <a:t>                    │  • Bridge between processes │          │</a:t>
+              <a:t>                    │  • Bridge between processes │</a:t>
             </a:r>
           </a:p>
           <a:p>
@@ -3934,7 +3934,7 @@
               </a:defRPr>
             </a:pPr>
             <a:r>
-              <a:t>                    │  • Sends file paths         │          │</a:t>
+              <a:t>                    │  • Sends file paths         │</a:t>
             </a:r>
           </a:p>
           <a:p>
@@ -3950,7 +3950,7 @@
               </a:defRPr>
             </a:pPr>
             <a:r>
-              <a:t>                    │  • Waits for completion     │          │</a:t>
+              <a:t>                    │  • Waits for completion     │</a:t>
             </a:r>
           </a:p>
           <a:p>
@@ -3966,39 +3966,7 @@
               </a:defRPr>
             </a:pPr>
             <a:r>
-              <a:t>                    └─────────────────────────────┘          │</a:t>
-            </a:r>
-          </a:p>
-          <a:p>
-            <a:pPr>
-              <a:spcAft>
-                <a:spcPts val="200"/>
-              </a:spcAft>
-              <a:defRPr sz="1100">
-                <a:solidFill>
-                  <a:srgbClr val="8B949E"/>
-                </a:solidFill>
-                <a:latin typeface="Consolas"/>
-              </a:defRPr>
-            </a:pPr>
-            <a:r>
-              <a:t>                                                              │</a:t>
-            </a:r>
-          </a:p>
-          <a:p>
-            <a:pPr>
-              <a:spcAft>
-                <a:spcPts val="200"/>
-              </a:spcAft>
-              <a:defRPr sz="1100">
-                <a:solidFill>
-                  <a:srgbClr val="8B949E"/>
-                </a:solidFill>
-                <a:latin typeface="Consolas"/>
-              </a:defRPr>
-            </a:pPr>
-            <a:r>
-              <a:t>                                                              └──▶</a:t>
+              <a:t>                    └─────────────────────────────┘</a:t>
             </a:r>
           </a:p>
           <a:p>

</xml_diff>